<commit_message>
Final system: bidirectional LoRa + WiFi-to-AWS cloud dashboard
- Single Node A (ESP32 + DHT22 + photoresistor) with an EVAL/ALARM
  environment-safety bonus state; Node B removed.
- Bidirectional LoRa: gateway ACKs every packet, Node A confirms in a
  WAITACK state (ACK sent before the WiFi POST to keep round-trip tight).
- Gateway joins WiFi and HTTP-POSTs JSON to a token-gated Flask service
  (cloud_app.py) deployed on AWS EC2, served at iot.gabr.online:8080,
  isolated by port from the unrelated service on that box.
- Secrets externalized: gitignored secrets.h + committed
  secrets.example.h; no credentials in tracked files.
- Docs (report.tex, README, slides, DEMO_VIDEO) rewritten to the final
  architecture; slides.pptx regenerated; diag_wifiscan helper added.

Co-Authored-By: Claude Opus 4.7 (1M context) <noreply@anthropic.com>
</commit_message>
<xml_diff>
--- a/docs/slides.pptx
+++ b/docs/slides.pptx
@@ -3185,7 +3185,7 @@
             </a:pPr>
             <a:r>
               <a:rPr/>
-              <a:t>Microprocessor Course — Project Discussion · 2026-05-17</a:t>
+              <a:t>Microprocessor Course — Project Discussion · 2026-05-18</a:t>
             </a:r>
           </a:p>
         </p:txBody>
@@ -3232,7 +3232,7 @@
             </a:pPr>
             <a:r>
               <a:rPr/>
-              <a:t>Key code — the state machine skeleton</a:t>
+              <a:t>Key code — the bonus safety rule</a:t>
             </a:r>
           </a:p>
         </p:txBody>
@@ -3256,19 +3256,19 @@
               <a:buNone/>
             </a:pPr>
             <a:r>
-              <a:rPr b="1">
-                <a:solidFill>
-                  <a:srgbClr val="007020"/>
-                </a:solidFill>
-                <a:latin typeface="Courier"/>
-              </a:rPr>
-              <a:t>enum</a:t>
-            </a:r>
-            <a:r>
-              <a:rPr>
-                <a:latin typeface="Courier"/>
-              </a:rPr>
-              <a:t> State </a:t>
+              <a:rPr>
+                <a:solidFill>
+                  <a:srgbClr val="902000"/>
+                </a:solidFill>
+                <a:latin typeface="Courier"/>
+              </a:rPr>
+              <a:t>bool</a:t>
+            </a:r>
+            <a:r>
+              <a:rPr>
+                <a:latin typeface="Courier"/>
+              </a:rPr>
+              <a:t> hot </a:t>
             </a:r>
             <a:r>
               <a:rPr>
@@ -3277,13 +3277,13 @@
                 </a:solidFill>
                 <a:latin typeface="Courier"/>
               </a:rPr>
-              <a:t>{</a:t>
-            </a:r>
-            <a:r>
-              <a:rPr>
-                <a:latin typeface="Courier"/>
-              </a:rPr>
-              <a:t> S_INIT</a:t>
+              <a:t>=</a:t>
+            </a:r>
+            <a:r>
+              <a:rPr>
+                <a:latin typeface="Courier"/>
+              </a:rPr>
+              <a:t> </a:t>
             </a:r>
             <a:r>
               <a:rPr>
@@ -3292,13 +3292,13 @@
                 </a:solidFill>
                 <a:latin typeface="Courier"/>
               </a:rPr>
-              <a:t>,</a:t>
-            </a:r>
-            <a:r>
-              <a:rPr>
-                <a:latin typeface="Courier"/>
-              </a:rPr>
-              <a:t> S_READ</a:t>
+              <a:t>(</a:t>
+            </a:r>
+            <a:r>
+              <a:rPr>
+                <a:latin typeface="Courier"/>
+              </a:rPr>
+              <a:t>tempC </a:t>
             </a:r>
             <a:r>
               <a:rPr>
@@ -3307,7 +3307,228 @@
                 </a:solidFill>
                 <a:latin typeface="Courier"/>
               </a:rPr>
-              <a:t>,</a:t>
+              <a:t>&gt;=</a:t>
+            </a:r>
+            <a:r>
+              <a:rPr>
+                <a:latin typeface="Courier"/>
+              </a:rPr>
+              <a:t> TEMP_HOT_C</a:t>
+            </a:r>
+            <a:r>
+              <a:rPr>
+                <a:solidFill>
+                  <a:srgbClr val="666666"/>
+                </a:solidFill>
+                <a:latin typeface="Courier"/>
+              </a:rPr>
+              <a:t>);</a:t>
+            </a:r>
+            <a:br/>
+            <a:r>
+              <a:rPr>
+                <a:solidFill>
+                  <a:srgbClr val="902000"/>
+                </a:solidFill>
+                <a:latin typeface="Courier"/>
+              </a:rPr>
+              <a:t>bool</a:t>
+            </a:r>
+            <a:r>
+              <a:rPr>
+                <a:latin typeface="Courier"/>
+              </a:rPr>
+              <a:t> condensation </a:t>
+            </a:r>
+            <a:r>
+              <a:rPr>
+                <a:solidFill>
+                  <a:srgbClr val="666666"/>
+                </a:solidFill>
+                <a:latin typeface="Courier"/>
+              </a:rPr>
+              <a:t>=</a:t>
+            </a:r>
+            <a:r>
+              <a:rPr>
+                <a:latin typeface="Courier"/>
+              </a:rPr>
+              <a:t> </a:t>
+            </a:r>
+            <a:r>
+              <a:rPr>
+                <a:solidFill>
+                  <a:srgbClr val="666666"/>
+                </a:solidFill>
+                <a:latin typeface="Courier"/>
+              </a:rPr>
+              <a:t>(</a:t>
+            </a:r>
+            <a:r>
+              <a:rPr>
+                <a:latin typeface="Courier"/>
+              </a:rPr>
+              <a:t>night </a:t>
+            </a:r>
+            <a:r>
+              <a:rPr>
+                <a:solidFill>
+                  <a:srgbClr val="666666"/>
+                </a:solidFill>
+                <a:latin typeface="Courier"/>
+              </a:rPr>
+              <a:t>==</a:t>
+            </a:r>
+            <a:r>
+              <a:rPr>
+                <a:latin typeface="Courier"/>
+              </a:rPr>
+              <a:t> </a:t>
+            </a:r>
+            <a:r>
+              <a:rPr>
+                <a:solidFill>
+                  <a:srgbClr val="40A070"/>
+                </a:solidFill>
+                <a:latin typeface="Courier"/>
+              </a:rPr>
+              <a:t>1</a:t>
+            </a:r>
+            <a:r>
+              <a:rPr>
+                <a:latin typeface="Courier"/>
+              </a:rPr>
+              <a:t> </a:t>
+            </a:r>
+            <a:r>
+              <a:rPr>
+                <a:solidFill>
+                  <a:srgbClr val="666666"/>
+                </a:solidFill>
+                <a:latin typeface="Courier"/>
+              </a:rPr>
+              <a:t>&amp;&amp;</a:t>
+            </a:r>
+            <a:r>
+              <a:rPr>
+                <a:latin typeface="Courier"/>
+              </a:rPr>
+              <a:t> humPct </a:t>
+            </a:r>
+            <a:r>
+              <a:rPr>
+                <a:solidFill>
+                  <a:srgbClr val="666666"/>
+                </a:solidFill>
+                <a:latin typeface="Courier"/>
+              </a:rPr>
+              <a:t>&gt;=</a:t>
+            </a:r>
+            <a:r>
+              <a:rPr>
+                <a:latin typeface="Courier"/>
+              </a:rPr>
+              <a:t> HUM_HIGH_PCT</a:t>
+            </a:r>
+            <a:r>
+              <a:rPr>
+                <a:solidFill>
+                  <a:srgbClr val="666666"/>
+                </a:solidFill>
+                <a:latin typeface="Courier"/>
+              </a:rPr>
+              <a:t>);</a:t>
+            </a:r>
+            <a:br/>
+            <a:r>
+              <a:rPr>
+                <a:latin typeface="Courier"/>
+              </a:rPr>
+              <a:t>state </a:t>
+            </a:r>
+            <a:r>
+              <a:rPr>
+                <a:solidFill>
+                  <a:srgbClr val="666666"/>
+                </a:solidFill>
+                <a:latin typeface="Courier"/>
+              </a:rPr>
+              <a:t>=</a:t>
+            </a:r>
+            <a:r>
+              <a:rPr>
+                <a:latin typeface="Courier"/>
+              </a:rPr>
+              <a:t> </a:t>
+            </a:r>
+            <a:r>
+              <a:rPr>
+                <a:solidFill>
+                  <a:srgbClr val="666666"/>
+                </a:solidFill>
+                <a:latin typeface="Courier"/>
+              </a:rPr>
+              <a:t>(</a:t>
+            </a:r>
+            <a:r>
+              <a:rPr>
+                <a:latin typeface="Courier"/>
+              </a:rPr>
+              <a:t>hot </a:t>
+            </a:r>
+            <a:r>
+              <a:rPr>
+                <a:solidFill>
+                  <a:srgbClr val="666666"/>
+                </a:solidFill>
+                <a:latin typeface="Courier"/>
+              </a:rPr>
+              <a:t>||</a:t>
+            </a:r>
+            <a:r>
+              <a:rPr>
+                <a:latin typeface="Courier"/>
+              </a:rPr>
+              <a:t> condensation</a:t>
+            </a:r>
+            <a:r>
+              <a:rPr>
+                <a:solidFill>
+                  <a:srgbClr val="666666"/>
+                </a:solidFill>
+                <a:latin typeface="Courier"/>
+              </a:rPr>
+              <a:t>)</a:t>
+            </a:r>
+            <a:r>
+              <a:rPr>
+                <a:latin typeface="Courier"/>
+              </a:rPr>
+              <a:t> </a:t>
+            </a:r>
+            <a:r>
+              <a:rPr>
+                <a:solidFill>
+                  <a:srgbClr val="666666"/>
+                </a:solidFill>
+                <a:latin typeface="Courier"/>
+              </a:rPr>
+              <a:t>?</a:t>
+            </a:r>
+            <a:r>
+              <a:rPr>
+                <a:latin typeface="Courier"/>
+              </a:rPr>
+              <a:t> S_ALARM </a:t>
+            </a:r>
+            <a:r>
+              <a:rPr>
+                <a:solidFill>
+                  <a:srgbClr val="666666"/>
+                </a:solidFill>
+                <a:latin typeface="Courier"/>
+              </a:rPr>
+              <a:t>:</a:t>
             </a:r>
             <a:r>
               <a:rPr>
@@ -3322,630 +3543,7 @@
                 </a:solidFill>
                 <a:latin typeface="Courier"/>
               </a:rPr>
-              <a:t>,</a:t>
-            </a:r>
-            <a:r>
-              <a:rPr>
-                <a:latin typeface="Courier"/>
-              </a:rPr>
-              <a:t> S_SEND</a:t>
-            </a:r>
-            <a:r>
-              <a:rPr>
-                <a:solidFill>
-                  <a:srgbClr val="666666"/>
-                </a:solidFill>
-                <a:latin typeface="Courier"/>
-              </a:rPr>
-              <a:t>,</a:t>
-            </a:r>
-            <a:r>
-              <a:rPr>
-                <a:latin typeface="Courier"/>
-              </a:rPr>
-              <a:t> S_WAIT</a:t>
-            </a:r>
-            <a:r>
-              <a:rPr>
-                <a:solidFill>
-                  <a:srgbClr val="666666"/>
-                </a:solidFill>
-                <a:latin typeface="Courier"/>
-              </a:rPr>
-              <a:t>,</a:t>
-            </a:r>
-            <a:r>
-              <a:rPr>
-                <a:latin typeface="Courier"/>
-              </a:rPr>
-              <a:t> S_ERROR </a:t>
-            </a:r>
-            <a:r>
-              <a:rPr>
-                <a:solidFill>
-                  <a:srgbClr val="666666"/>
-                </a:solidFill>
-                <a:latin typeface="Courier"/>
-              </a:rPr>
-              <a:t>};</a:t>
-            </a:r>
-            <a:br/>
-            <a:r>
-              <a:rPr>
-                <a:latin typeface="Courier"/>
-              </a:rPr>
-              <a:t>State state </a:t>
-            </a:r>
-            <a:r>
-              <a:rPr>
-                <a:solidFill>
-                  <a:srgbClr val="666666"/>
-                </a:solidFill>
-                <a:latin typeface="Courier"/>
-              </a:rPr>
-              <a:t>=</a:t>
-            </a:r>
-            <a:r>
-              <a:rPr>
-                <a:latin typeface="Courier"/>
-              </a:rPr>
-              <a:t> S_INIT</a:t>
-            </a:r>
-            <a:r>
-              <a:rPr>
-                <a:solidFill>
-                  <a:srgbClr val="666666"/>
-                </a:solidFill>
-                <a:latin typeface="Courier"/>
-              </a:rPr>
               <a:t>;</a:t>
-            </a:r>
-            <a:br/>
-            <a:r>
-              <a:rPr>
-                <a:solidFill>
-                  <a:srgbClr val="902000"/>
-                </a:solidFill>
-                <a:latin typeface="Courier"/>
-              </a:rPr>
-              <a:t>void</a:t>
-            </a:r>
-            <a:r>
-              <a:rPr>
-                <a:latin typeface="Courier"/>
-              </a:rPr>
-              <a:t> loop</a:t>
-            </a:r>
-            <a:r>
-              <a:rPr>
-                <a:solidFill>
-                  <a:srgbClr val="666666"/>
-                </a:solidFill>
-                <a:latin typeface="Courier"/>
-              </a:rPr>
-              <a:t>()</a:t>
-            </a:r>
-            <a:r>
-              <a:rPr>
-                <a:latin typeface="Courier"/>
-              </a:rPr>
-              <a:t> </a:t>
-            </a:r>
-            <a:r>
-              <a:rPr>
-                <a:solidFill>
-                  <a:srgbClr val="666666"/>
-                </a:solidFill>
-                <a:latin typeface="Courier"/>
-              </a:rPr>
-              <a:t>{</a:t>
-            </a:r>
-            <a:br/>
-            <a:r>
-              <a:rPr>
-                <a:latin typeface="Courier"/>
-              </a:rPr>
-              <a:t>  </a:t>
-            </a:r>
-            <a:r>
-              <a:rPr b="1">
-                <a:solidFill>
-                  <a:srgbClr val="007020"/>
-                </a:solidFill>
-                <a:latin typeface="Courier"/>
-              </a:rPr>
-              <a:t>switch</a:t>
-            </a:r>
-            <a:r>
-              <a:rPr>
-                <a:latin typeface="Courier"/>
-              </a:rPr>
-              <a:t> </a:t>
-            </a:r>
-            <a:r>
-              <a:rPr>
-                <a:solidFill>
-                  <a:srgbClr val="666666"/>
-                </a:solidFill>
-                <a:latin typeface="Courier"/>
-              </a:rPr>
-              <a:t>(</a:t>
-            </a:r>
-            <a:r>
-              <a:rPr>
-                <a:latin typeface="Courier"/>
-              </a:rPr>
-              <a:t>state</a:t>
-            </a:r>
-            <a:r>
-              <a:rPr>
-                <a:solidFill>
-                  <a:srgbClr val="666666"/>
-                </a:solidFill>
-                <a:latin typeface="Courier"/>
-              </a:rPr>
-              <a:t>)</a:t>
-            </a:r>
-            <a:r>
-              <a:rPr>
-                <a:latin typeface="Courier"/>
-              </a:rPr>
-              <a:t> </a:t>
-            </a:r>
-            <a:r>
-              <a:rPr>
-                <a:solidFill>
-                  <a:srgbClr val="666666"/>
-                </a:solidFill>
-                <a:latin typeface="Courier"/>
-              </a:rPr>
-              <a:t>{</a:t>
-            </a:r>
-            <a:br/>
-            <a:r>
-              <a:rPr>
-                <a:latin typeface="Courier"/>
-              </a:rPr>
-              <a:t>    </a:t>
-            </a:r>
-            <a:r>
-              <a:rPr b="1">
-                <a:solidFill>
-                  <a:srgbClr val="007020"/>
-                </a:solidFill>
-                <a:latin typeface="Courier"/>
-              </a:rPr>
-              <a:t>case</a:t>
-            </a:r>
-            <a:r>
-              <a:rPr>
-                <a:latin typeface="Courier"/>
-              </a:rPr>
-              <a:t> S_INIT</a:t>
-            </a:r>
-            <a:r>
-              <a:rPr>
-                <a:solidFill>
-                  <a:srgbClr val="666666"/>
-                </a:solidFill>
-                <a:latin typeface="Courier"/>
-              </a:rPr>
-              <a:t>:</a:t>
-            </a:r>
-            <a:r>
-              <a:rPr>
-                <a:latin typeface="Courier"/>
-              </a:rPr>
-              <a:t>  </a:t>
-            </a:r>
-            <a:r>
-              <a:rPr i="1">
-                <a:solidFill>
-                  <a:srgbClr val="60A0B0"/>
-                </a:solidFill>
-                <a:latin typeface="Courier"/>
-              </a:rPr>
-              <a:t>/* bring up sensors + radio */</a:t>
-            </a:r>
-            <a:r>
-              <a:rPr>
-                <a:latin typeface="Courier"/>
-              </a:rPr>
-              <a:t>        </a:t>
-            </a:r>
-            <a:r>
-              <a:rPr b="1">
-                <a:solidFill>
-                  <a:srgbClr val="007020"/>
-                </a:solidFill>
-                <a:latin typeface="Courier"/>
-              </a:rPr>
-              <a:t>break</a:t>
-            </a:r>
-            <a:r>
-              <a:rPr>
-                <a:solidFill>
-                  <a:srgbClr val="666666"/>
-                </a:solidFill>
-                <a:latin typeface="Courier"/>
-              </a:rPr>
-              <a:t>;</a:t>
-            </a:r>
-            <a:br/>
-            <a:r>
-              <a:rPr>
-                <a:latin typeface="Courier"/>
-              </a:rPr>
-              <a:t>    </a:t>
-            </a:r>
-            <a:r>
-              <a:rPr b="1">
-                <a:solidFill>
-                  <a:srgbClr val="007020"/>
-                </a:solidFill>
-                <a:latin typeface="Courier"/>
-              </a:rPr>
-              <a:t>case</a:t>
-            </a:r>
-            <a:r>
-              <a:rPr>
-                <a:latin typeface="Courier"/>
-              </a:rPr>
-              <a:t> S_READ</a:t>
-            </a:r>
-            <a:r>
-              <a:rPr>
-                <a:solidFill>
-                  <a:srgbClr val="666666"/>
-                </a:solidFill>
-                <a:latin typeface="Courier"/>
-              </a:rPr>
-              <a:t>:</a:t>
-            </a:r>
-            <a:r>
-              <a:rPr>
-                <a:latin typeface="Courier"/>
-              </a:rPr>
-              <a:t>  </a:t>
-            </a:r>
-            <a:r>
-              <a:rPr i="1">
-                <a:solidFill>
-                  <a:srgbClr val="60A0B0"/>
-                </a:solidFill>
-                <a:latin typeface="Courier"/>
-              </a:rPr>
-              <a:t>/* sample; bad read -&gt; S_ERROR */</a:t>
-            </a:r>
-            <a:r>
-              <a:rPr>
-                <a:latin typeface="Courier"/>
-              </a:rPr>
-              <a:t>     </a:t>
-            </a:r>
-            <a:r>
-              <a:rPr b="1">
-                <a:solidFill>
-                  <a:srgbClr val="007020"/>
-                </a:solidFill>
-                <a:latin typeface="Courier"/>
-              </a:rPr>
-              <a:t>break</a:t>
-            </a:r>
-            <a:r>
-              <a:rPr>
-                <a:solidFill>
-                  <a:srgbClr val="666666"/>
-                </a:solidFill>
-                <a:latin typeface="Courier"/>
-              </a:rPr>
-              <a:t>;</a:t>
-            </a:r>
-            <a:br/>
-            <a:r>
-              <a:rPr>
-                <a:latin typeface="Courier"/>
-              </a:rPr>
-              <a:t>    </a:t>
-            </a:r>
-            <a:r>
-              <a:rPr b="1">
-                <a:solidFill>
-                  <a:srgbClr val="007020"/>
-                </a:solidFill>
-                <a:latin typeface="Courier"/>
-              </a:rPr>
-              <a:t>case</a:t>
-            </a:r>
-            <a:r>
-              <a:rPr>
-                <a:latin typeface="Courier"/>
-              </a:rPr>
-              <a:t> S_BUILD</a:t>
-            </a:r>
-            <a:r>
-              <a:rPr>
-                <a:solidFill>
-                  <a:srgbClr val="666666"/>
-                </a:solidFill>
-                <a:latin typeface="Courier"/>
-              </a:rPr>
-              <a:t>:</a:t>
-            </a:r>
-            <a:r>
-              <a:rPr>
-                <a:latin typeface="Courier"/>
-              </a:rPr>
-              <a:t> </a:t>
-            </a:r>
-            <a:r>
-              <a:rPr i="1">
-                <a:solidFill>
-                  <a:srgbClr val="60A0B0"/>
-                </a:solidFill>
-                <a:latin typeface="Courier"/>
-              </a:rPr>
-              <a:t>/* snprintf the CSV payload */</a:t>
-            </a:r>
-            <a:r>
-              <a:rPr>
-                <a:latin typeface="Courier"/>
-              </a:rPr>
-              <a:t>        </a:t>
-            </a:r>
-            <a:r>
-              <a:rPr b="1">
-                <a:solidFill>
-                  <a:srgbClr val="007020"/>
-                </a:solidFill>
-                <a:latin typeface="Courier"/>
-              </a:rPr>
-              <a:t>break</a:t>
-            </a:r>
-            <a:r>
-              <a:rPr>
-                <a:solidFill>
-                  <a:srgbClr val="666666"/>
-                </a:solidFill>
-                <a:latin typeface="Courier"/>
-              </a:rPr>
-              <a:t>;</a:t>
-            </a:r>
-            <a:br/>
-            <a:r>
-              <a:rPr>
-                <a:latin typeface="Courier"/>
-              </a:rPr>
-              <a:t>    </a:t>
-            </a:r>
-            <a:r>
-              <a:rPr b="1">
-                <a:solidFill>
-                  <a:srgbClr val="007020"/>
-                </a:solidFill>
-                <a:latin typeface="Courier"/>
-              </a:rPr>
-              <a:t>case</a:t>
-            </a:r>
-            <a:r>
-              <a:rPr>
-                <a:latin typeface="Courier"/>
-              </a:rPr>
-              <a:t> S_SEND</a:t>
-            </a:r>
-            <a:r>
-              <a:rPr>
-                <a:solidFill>
-                  <a:srgbClr val="666666"/>
-                </a:solidFill>
-                <a:latin typeface="Courier"/>
-              </a:rPr>
-              <a:t>:</a:t>
-            </a:r>
-            <a:r>
-              <a:rPr>
-                <a:latin typeface="Courier"/>
-              </a:rPr>
-              <a:t>  </a:t>
-            </a:r>
-            <a:r>
-              <a:rPr i="1">
-                <a:solidFill>
-                  <a:srgbClr val="60A0B0"/>
-                </a:solidFill>
-                <a:latin typeface="Courier"/>
-              </a:rPr>
-              <a:t>/* LoRa transmit (or USB fallback) */</a:t>
-            </a:r>
-            <a:r>
-              <a:rPr>
-                <a:latin typeface="Courier"/>
-              </a:rPr>
-              <a:t> </a:t>
-            </a:r>
-            <a:r>
-              <a:rPr b="1">
-                <a:solidFill>
-                  <a:srgbClr val="007020"/>
-                </a:solidFill>
-                <a:latin typeface="Courier"/>
-              </a:rPr>
-              <a:t>break</a:t>
-            </a:r>
-            <a:r>
-              <a:rPr>
-                <a:solidFill>
-                  <a:srgbClr val="666666"/>
-                </a:solidFill>
-                <a:latin typeface="Courier"/>
-              </a:rPr>
-              <a:t>;</a:t>
-            </a:r>
-            <a:br/>
-            <a:r>
-              <a:rPr>
-                <a:latin typeface="Courier"/>
-              </a:rPr>
-              <a:t>    </a:t>
-            </a:r>
-            <a:r>
-              <a:rPr b="1">
-                <a:solidFill>
-                  <a:srgbClr val="007020"/>
-                </a:solidFill>
-                <a:latin typeface="Courier"/>
-              </a:rPr>
-              <a:t>case</a:t>
-            </a:r>
-            <a:r>
-              <a:rPr>
-                <a:latin typeface="Courier"/>
-              </a:rPr>
-              <a:t> S_WAIT</a:t>
-            </a:r>
-            <a:r>
-              <a:rPr>
-                <a:solidFill>
-                  <a:srgbClr val="666666"/>
-                </a:solidFill>
-                <a:latin typeface="Courier"/>
-              </a:rPr>
-              <a:t>:</a:t>
-            </a:r>
-            <a:r>
-              <a:rPr>
-                <a:latin typeface="Courier"/>
-              </a:rPr>
-              <a:t>  </a:t>
-            </a:r>
-            <a:r>
-              <a:rPr i="1">
-                <a:solidFill>
-                  <a:srgbClr val="60A0B0"/>
-                </a:solidFill>
-                <a:latin typeface="Courier"/>
-              </a:rPr>
-              <a:t>/* hold for the sense period */</a:t>
-            </a:r>
-            <a:r>
-              <a:rPr>
-                <a:latin typeface="Courier"/>
-              </a:rPr>
-              <a:t>       </a:t>
-            </a:r>
-            <a:r>
-              <a:rPr b="1">
-                <a:solidFill>
-                  <a:srgbClr val="007020"/>
-                </a:solidFill>
-                <a:latin typeface="Courier"/>
-              </a:rPr>
-              <a:t>break</a:t>
-            </a:r>
-            <a:r>
-              <a:rPr>
-                <a:solidFill>
-                  <a:srgbClr val="666666"/>
-                </a:solidFill>
-                <a:latin typeface="Courier"/>
-              </a:rPr>
-              <a:t>;</a:t>
-            </a:r>
-            <a:br/>
-            <a:r>
-              <a:rPr>
-                <a:latin typeface="Courier"/>
-              </a:rPr>
-              <a:t>    </a:t>
-            </a:r>
-            <a:r>
-              <a:rPr b="1">
-                <a:solidFill>
-                  <a:srgbClr val="007020"/>
-                </a:solidFill>
-                <a:latin typeface="Courier"/>
-              </a:rPr>
-              <a:t>case</a:t>
-            </a:r>
-            <a:r>
-              <a:rPr>
-                <a:latin typeface="Courier"/>
-              </a:rPr>
-              <a:t> S_ERROR</a:t>
-            </a:r>
-            <a:r>
-              <a:rPr>
-                <a:solidFill>
-                  <a:srgbClr val="666666"/>
-                </a:solidFill>
-                <a:latin typeface="Courier"/>
-              </a:rPr>
-              <a:t>:</a:t>
-            </a:r>
-            <a:r>
-              <a:rPr>
-                <a:latin typeface="Courier"/>
-              </a:rPr>
-              <a:t> </a:t>
-            </a:r>
-            <a:r>
-              <a:rPr i="1">
-                <a:solidFill>
-                  <a:srgbClr val="60A0B0"/>
-                </a:solidFill>
-                <a:latin typeface="Courier"/>
-              </a:rPr>
-              <a:t>/* delay, retry -&gt; S_INIT */</a:t>
-            </a:r>
-            <a:r>
-              <a:rPr>
-                <a:latin typeface="Courier"/>
-              </a:rPr>
-              <a:t>          </a:t>
-            </a:r>
-            <a:r>
-              <a:rPr b="1">
-                <a:solidFill>
-                  <a:srgbClr val="007020"/>
-                </a:solidFill>
-                <a:latin typeface="Courier"/>
-              </a:rPr>
-              <a:t>break</a:t>
-            </a:r>
-            <a:r>
-              <a:rPr>
-                <a:solidFill>
-                  <a:srgbClr val="666666"/>
-                </a:solidFill>
-                <a:latin typeface="Courier"/>
-              </a:rPr>
-              <a:t>;</a:t>
-            </a:r>
-            <a:br/>
-            <a:r>
-              <a:rPr>
-                <a:latin typeface="Courier"/>
-              </a:rPr>
-              <a:t>  </a:t>
-            </a:r>
-            <a:r>
-              <a:rPr>
-                <a:solidFill>
-                  <a:srgbClr val="666666"/>
-                </a:solidFill>
-                <a:latin typeface="Courier"/>
-              </a:rPr>
-              <a:t>}</a:t>
-            </a:r>
-            <a:br/>
-            <a:r>
-              <a:rPr>
-                <a:solidFill>
-                  <a:srgbClr val="666666"/>
-                </a:solidFill>
-                <a:latin typeface="Courier"/>
-              </a:rPr>
-              <a:t>}</a:t>
             </a:r>
           </a:p>
         </p:txBody>
@@ -3992,7 +3590,7 @@
             </a:pPr>
             <a:r>
               <a:rPr/>
-              <a:t>Key code — the bonus security rule</a:t>
+              <a:t>Key code — bidirectional ACK</a:t>
             </a:r>
           </a:p>
         </p:txBody>
@@ -4016,19 +3614,192 @@
               <a:buNone/>
             </a:pPr>
             <a:r>
+              <a:rPr i="1">
+                <a:solidFill>
+                  <a:srgbClr val="60A0B0"/>
+                </a:solidFill>
+                <a:latin typeface="Courier"/>
+              </a:rPr>
+              <a:t>// gateway, on each received packet:</a:t>
+            </a:r>
+            <a:br/>
+            <a:r>
+              <a:rPr>
+                <a:latin typeface="Courier"/>
+              </a:rPr>
+              <a:t>sendAck</a:t>
+            </a:r>
+            <a:r>
+              <a:rPr>
+                <a:solidFill>
+                  <a:srgbClr val="666666"/>
+                </a:solidFill>
+                <a:latin typeface="Courier"/>
+              </a:rPr>
+              <a:t>(</a:t>
+            </a:r>
+            <a:r>
+              <a:rPr>
+                <a:latin typeface="Courier"/>
+              </a:rPr>
+              <a:t>seq</a:t>
+            </a:r>
+            <a:r>
+              <a:rPr>
+                <a:solidFill>
+                  <a:srgbClr val="666666"/>
+                </a:solidFill>
+                <a:latin typeface="Courier"/>
+              </a:rPr>
+              <a:t>);</a:t>
+            </a:r>
+            <a:r>
+              <a:rPr>
+                <a:latin typeface="Courier"/>
+              </a:rPr>
+              <a:t>          </a:t>
+            </a:r>
+            <a:r>
+              <a:rPr i="1">
+                <a:solidFill>
+                  <a:srgbClr val="60A0B0"/>
+                </a:solidFill>
+                <a:latin typeface="Courier"/>
+              </a:rPr>
+              <a:t>// LoRa TX back to node (fast, first)</a:t>
+            </a:r>
+            <a:br/>
+            <a:r>
+              <a:rPr>
+                <a:latin typeface="Courier"/>
+              </a:rPr>
+              <a:t>Serial</a:t>
+            </a:r>
+            <a:r>
+              <a:rPr>
+                <a:solidFill>
+                  <a:srgbClr val="666666"/>
+                </a:solidFill>
+                <a:latin typeface="Courier"/>
+              </a:rPr>
+              <a:t>.</a:t>
+            </a:r>
+            <a:r>
+              <a:rPr>
+                <a:latin typeface="Courier"/>
+              </a:rPr>
+              <a:t>println</a:t>
+            </a:r>
+            <a:r>
+              <a:rPr>
+                <a:solidFill>
+                  <a:srgbClr val="666666"/>
+                </a:solidFill>
+                <a:latin typeface="Courier"/>
+              </a:rPr>
+              <a:t>(</a:t>
+            </a:r>
+            <a:r>
+              <a:rPr>
+                <a:latin typeface="Courier"/>
+              </a:rPr>
+              <a:t>out</a:t>
+            </a:r>
+            <a:r>
+              <a:rPr>
+                <a:solidFill>
+                  <a:srgbClr val="666666"/>
+                </a:solidFill>
+                <a:latin typeface="Courier"/>
+              </a:rPr>
+              <a:t>);</a:t>
+            </a:r>
+            <a:r>
+              <a:rPr>
+                <a:latin typeface="Courier"/>
+              </a:rPr>
+              <a:t>   </a:t>
+            </a:r>
+            <a:r>
+              <a:rPr i="1">
+                <a:solidFill>
+                  <a:srgbClr val="60A0B0"/>
+                </a:solidFill>
+                <a:latin typeface="Courier"/>
+              </a:rPr>
+              <a:t>// local debug</a:t>
+            </a:r>
+            <a:br/>
+            <a:r>
+              <a:rPr>
+                <a:latin typeface="Courier"/>
+              </a:rPr>
+              <a:t>cloudPost</a:t>
+            </a:r>
+            <a:r>
+              <a:rPr>
+                <a:solidFill>
+                  <a:srgbClr val="666666"/>
+                </a:solidFill>
+                <a:latin typeface="Courier"/>
+              </a:rPr>
+              <a:t>(</a:t>
+            </a:r>
+            <a:r>
+              <a:rPr>
+                <a:latin typeface="Courier"/>
+              </a:rPr>
+              <a:t>out</a:t>
+            </a:r>
+            <a:r>
+              <a:rPr>
+                <a:solidFill>
+                  <a:srgbClr val="666666"/>
+                </a:solidFill>
+                <a:latin typeface="Courier"/>
+              </a:rPr>
+              <a:t>);</a:t>
+            </a:r>
+            <a:r>
+              <a:rPr>
+                <a:latin typeface="Courier"/>
+              </a:rPr>
+              <a:t>        </a:t>
+            </a:r>
+            <a:r>
+              <a:rPr i="1">
+                <a:solidFill>
+                  <a:srgbClr val="60A0B0"/>
+                </a:solidFill>
+                <a:latin typeface="Courier"/>
+              </a:rPr>
+              <a:t>// WiFi HTTP POST (may block; done last)</a:t>
+            </a:r>
+            <a:br/>
+            <a:r>
+              <a:rPr i="1">
+                <a:solidFill>
+                  <a:srgbClr val="60A0B0"/>
+                </a:solidFill>
+                <a:latin typeface="Courier"/>
+              </a:rPr>
+              <a:t>// node, WAITACK:</a:t>
+            </a:r>
+            <a:br/>
+            <a:r>
               <a:rPr b="1">
                 <a:solidFill>
                   <a:srgbClr val="007020"/>
                 </a:solidFill>
                 <a:latin typeface="Courier"/>
               </a:rPr>
-              <a:t>case</a:t>
-            </a:r>
-            <a:r>
-              <a:rPr>
-                <a:latin typeface="Courier"/>
-              </a:rPr>
-              <a:t> S_EVAL</a:t>
+              <a:t>if</a:t>
+            </a:r>
+            <a:r>
+              <a:rPr>
+                <a:latin typeface="Courier"/>
+              </a:rPr>
+              <a:t> </a:t>
             </a:r>
             <a:r>
               <a:rPr>
@@ -4037,23 +3808,82 @@
                 </a:solidFill>
                 <a:latin typeface="Courier"/>
               </a:rPr>
-              <a:t>:</a:t>
-            </a:r>
-            <a:br/>
-            <a:r>
-              <a:rPr>
-                <a:latin typeface="Courier"/>
-              </a:rPr>
-              <a:t>  </a:t>
-            </a:r>
-            <a:r>
-              <a:rPr b="1">
-                <a:solidFill>
-                  <a:srgbClr val="007020"/>
-                </a:solidFill>
-                <a:latin typeface="Courier"/>
-              </a:rPr>
-              <a:t>if</a:t>
+              <a:t>(</a:t>
+            </a:r>
+            <a:r>
+              <a:rPr>
+                <a:latin typeface="Courier"/>
+              </a:rPr>
+              <a:t>strncmp</a:t>
+            </a:r>
+            <a:r>
+              <a:rPr>
+                <a:solidFill>
+                  <a:srgbClr val="666666"/>
+                </a:solidFill>
+                <a:latin typeface="Courier"/>
+              </a:rPr>
+              <a:t>(</a:t>
+            </a:r>
+            <a:r>
+              <a:rPr>
+                <a:latin typeface="Courier"/>
+              </a:rPr>
+              <a:t>rx</a:t>
+            </a:r>
+            <a:r>
+              <a:rPr>
+                <a:solidFill>
+                  <a:srgbClr val="666666"/>
+                </a:solidFill>
+                <a:latin typeface="Courier"/>
+              </a:rPr>
+              <a:t>,</a:t>
+            </a:r>
+            <a:r>
+              <a:rPr>
+                <a:solidFill>
+                  <a:srgbClr val="4070A0"/>
+                </a:solidFill>
+                <a:latin typeface="Courier"/>
+              </a:rPr>
+              <a:t>"ACK,"</a:t>
+            </a:r>
+            <a:r>
+              <a:rPr>
+                <a:solidFill>
+                  <a:srgbClr val="666666"/>
+                </a:solidFill>
+                <a:latin typeface="Courier"/>
+              </a:rPr>
+              <a:t>,</a:t>
+            </a:r>
+            <a:r>
+              <a:rPr>
+                <a:solidFill>
+                  <a:srgbClr val="40A070"/>
+                </a:solidFill>
+                <a:latin typeface="Courier"/>
+              </a:rPr>
+              <a:t>4</a:t>
+            </a:r>
+            <a:r>
+              <a:rPr>
+                <a:solidFill>
+                  <a:srgbClr val="666666"/>
+                </a:solidFill>
+                <a:latin typeface="Courier"/>
+              </a:rPr>
+              <a:t>)==</a:t>
+            </a:r>
+            <a:r>
+              <a:rPr>
+                <a:solidFill>
+                  <a:srgbClr val="40A070"/>
+                </a:solidFill>
+                <a:latin typeface="Courier"/>
+              </a:rPr>
+              <a:t>0</a:t>
             </a:r>
             <a:r>
               <a:rPr>
@@ -4068,13 +3898,28 @@
                 </a:solidFill>
                 <a:latin typeface="Courier"/>
               </a:rPr>
+              <a:t>&amp;&amp;</a:t>
+            </a:r>
+            <a:r>
+              <a:rPr>
+                <a:latin typeface="Courier"/>
+              </a:rPr>
+              <a:t> strtoul</a:t>
+            </a:r>
+            <a:r>
+              <a:rPr>
+                <a:solidFill>
+                  <a:srgbClr val="666666"/>
+                </a:solidFill>
+                <a:latin typeface="Courier"/>
+              </a:rPr>
               <a:t>(</a:t>
             </a:r>
             <a:r>
               <a:rPr>
                 <a:latin typeface="Courier"/>
               </a:rPr>
-              <a:t>pir </a:t>
+              <a:t>rx</a:t>
             </a:r>
             <a:r>
               <a:rPr>
@@ -4083,13 +3928,7 @@
                 </a:solidFill>
                 <a:latin typeface="Courier"/>
               </a:rPr>
-              <a:t>==</a:t>
-            </a:r>
-            <a:r>
-              <a:rPr>
-                <a:latin typeface="Courier"/>
-              </a:rPr>
-              <a:t> </a:t>
+              <a:t>+</a:t>
             </a:r>
             <a:r>
               <a:rPr>
@@ -4098,478 +3937,91 @@
                 </a:solidFill>
                 <a:latin typeface="Courier"/>
               </a:rPr>
+              <a:t>4</a:t>
+            </a:r>
+            <a:r>
+              <a:rPr>
+                <a:solidFill>
+                  <a:srgbClr val="666666"/>
+                </a:solidFill>
+                <a:latin typeface="Courier"/>
+              </a:rPr>
+              <a:t>,</a:t>
+            </a:r>
+            <a:r>
+              <a:rPr>
+                <a:solidFill>
+                  <a:srgbClr val="40A070"/>
+                </a:solidFill>
+                <a:latin typeface="Courier"/>
+              </a:rPr>
+              <a:t>0</a:t>
+            </a:r>
+            <a:r>
+              <a:rPr>
+                <a:solidFill>
+                  <a:srgbClr val="666666"/>
+                </a:solidFill>
+                <a:latin typeface="Courier"/>
+              </a:rPr>
+              <a:t>,</a:t>
+            </a:r>
+            <a:r>
+              <a:rPr>
+                <a:solidFill>
+                  <a:srgbClr val="40A070"/>
+                </a:solidFill>
+                <a:latin typeface="Courier"/>
+              </a:rPr>
+              <a:t>10</a:t>
+            </a:r>
+            <a:r>
+              <a:rPr>
+                <a:solidFill>
+                  <a:srgbClr val="666666"/>
+                </a:solidFill>
+                <a:latin typeface="Courier"/>
+              </a:rPr>
+              <a:t>)==</a:t>
+            </a:r>
+            <a:r>
+              <a:rPr>
+                <a:latin typeface="Courier"/>
+              </a:rPr>
+              <a:t>sentSeq</a:t>
+            </a:r>
+            <a:r>
+              <a:rPr>
+                <a:solidFill>
+                  <a:srgbClr val="666666"/>
+                </a:solidFill>
+                <a:latin typeface="Courier"/>
+              </a:rPr>
+              <a:t>)</a:t>
+            </a:r>
+            <a:r>
+              <a:rPr>
+                <a:latin typeface="Courier"/>
+              </a:rPr>
+              <a:t> ackOk</a:t>
+            </a:r>
+            <a:r>
+              <a:rPr>
+                <a:solidFill>
+                  <a:srgbClr val="666666"/>
+                </a:solidFill>
+                <a:latin typeface="Courier"/>
+              </a:rPr>
+              <a:t>=</a:t>
+            </a:r>
+            <a:r>
+              <a:rPr>
+                <a:solidFill>
+                  <a:srgbClr val="40A070"/>
+                </a:solidFill>
+                <a:latin typeface="Courier"/>
+              </a:rPr>
               <a:t>1</a:t>
-            </a:r>
-            <a:r>
-              <a:rPr>
-                <a:latin typeface="Courier"/>
-              </a:rPr>
-              <a:t> </a:t>
-            </a:r>
-            <a:r>
-              <a:rPr>
-                <a:solidFill>
-                  <a:srgbClr val="666666"/>
-                </a:solidFill>
-                <a:latin typeface="Courier"/>
-              </a:rPr>
-              <a:t>&amp;&amp;</a:t>
-            </a:r>
-            <a:r>
-              <a:rPr>
-                <a:latin typeface="Courier"/>
-              </a:rPr>
-              <a:t> doorOpen </a:t>
-            </a:r>
-            <a:r>
-              <a:rPr>
-                <a:solidFill>
-                  <a:srgbClr val="666666"/>
-                </a:solidFill>
-                <a:latin typeface="Courier"/>
-              </a:rPr>
-              <a:t>==</a:t>
-            </a:r>
-            <a:r>
-              <a:rPr>
-                <a:latin typeface="Courier"/>
-              </a:rPr>
-              <a:t> </a:t>
-            </a:r>
-            <a:r>
-              <a:rPr>
-                <a:solidFill>
-                  <a:srgbClr val="40A070"/>
-                </a:solidFill>
-                <a:latin typeface="Courier"/>
-              </a:rPr>
-              <a:t>1</a:t>
-            </a:r>
-            <a:r>
-              <a:rPr>
-                <a:solidFill>
-                  <a:srgbClr val="666666"/>
-                </a:solidFill>
-                <a:latin typeface="Courier"/>
-              </a:rPr>
-              <a:t>)</a:t>
-            </a:r>
-            <a:r>
-              <a:rPr>
-                <a:latin typeface="Courier"/>
-              </a:rPr>
-              <a:t> state </a:t>
-            </a:r>
-            <a:r>
-              <a:rPr>
-                <a:solidFill>
-                  <a:srgbClr val="666666"/>
-                </a:solidFill>
-                <a:latin typeface="Courier"/>
-              </a:rPr>
-              <a:t>=</a:t>
-            </a:r>
-            <a:r>
-              <a:rPr>
-                <a:latin typeface="Courier"/>
-              </a:rPr>
-              <a:t> S_ALARM</a:t>
-            </a:r>
-            <a:r>
-              <a:rPr>
-                <a:solidFill>
-                  <a:srgbClr val="666666"/>
-                </a:solidFill>
-                <a:latin typeface="Courier"/>
-              </a:rPr>
-              <a:t>;</a:t>
-            </a:r>
-            <a:r>
-              <a:rPr>
-                <a:latin typeface="Courier"/>
-              </a:rPr>
-              <a:t>     </a:t>
-            </a:r>
-            <a:r>
-              <a:rPr i="1">
-                <a:solidFill>
-                  <a:srgbClr val="60A0B0"/>
-                </a:solidFill>
-                <a:latin typeface="Courier"/>
-              </a:rPr>
-              <a:t>// intrusion</a:t>
-            </a:r>
-            <a:br/>
-            <a:r>
-              <a:rPr>
-                <a:latin typeface="Courier"/>
-              </a:rPr>
-              <a:t>  </a:t>
-            </a:r>
-            <a:r>
-              <a:rPr b="1">
-                <a:solidFill>
-                  <a:srgbClr val="007020"/>
-                </a:solidFill>
-                <a:latin typeface="Courier"/>
-              </a:rPr>
-              <a:t>else</a:t>
-            </a:r>
-            <a:r>
-              <a:rPr>
-                <a:latin typeface="Courier"/>
-              </a:rPr>
-              <a:t> </a:t>
-            </a:r>
-            <a:r>
-              <a:rPr>
-                <a:solidFill>
-                  <a:srgbClr val="666666"/>
-                </a:solidFill>
-                <a:latin typeface="Courier"/>
-              </a:rPr>
-              <a:t>{</a:t>
-            </a:r>
-            <a:r>
-              <a:rPr>
-                <a:latin typeface="Courier"/>
-              </a:rPr>
-              <a:t> alarm </a:t>
-            </a:r>
-            <a:r>
-              <a:rPr>
-                <a:solidFill>
-                  <a:srgbClr val="666666"/>
-                </a:solidFill>
-                <a:latin typeface="Courier"/>
-              </a:rPr>
-              <a:t>=</a:t>
-            </a:r>
-            <a:r>
-              <a:rPr>
-                <a:latin typeface="Courier"/>
-              </a:rPr>
-              <a:t> </a:t>
-            </a:r>
-            <a:r>
-              <a:rPr>
-                <a:solidFill>
-                  <a:srgbClr val="40A070"/>
-                </a:solidFill>
-                <a:latin typeface="Courier"/>
-              </a:rPr>
-              <a:t>0</a:t>
-            </a:r>
-            <a:r>
-              <a:rPr>
-                <a:solidFill>
-                  <a:srgbClr val="666666"/>
-                </a:solidFill>
-                <a:latin typeface="Courier"/>
-              </a:rPr>
-              <a:t>;</a:t>
-            </a:r>
-            <a:r>
-              <a:rPr>
-                <a:latin typeface="Courier"/>
-              </a:rPr>
-              <a:t> digitalWrite</a:t>
-            </a:r>
-            <a:r>
-              <a:rPr>
-                <a:solidFill>
-                  <a:srgbClr val="666666"/>
-                </a:solidFill>
-                <a:latin typeface="Courier"/>
-              </a:rPr>
-              <a:t>(</a:t>
-            </a:r>
-            <a:r>
-              <a:rPr>
-                <a:latin typeface="Courier"/>
-              </a:rPr>
-              <a:t>BUZZER</a:t>
-            </a:r>
-            <a:r>
-              <a:rPr>
-                <a:solidFill>
-                  <a:srgbClr val="666666"/>
-                </a:solidFill>
-                <a:latin typeface="Courier"/>
-              </a:rPr>
-              <a:t>,</a:t>
-            </a:r>
-            <a:r>
-              <a:rPr>
-                <a:latin typeface="Courier"/>
-              </a:rPr>
-              <a:t>LOW</a:t>
-            </a:r>
-            <a:r>
-              <a:rPr>
-                <a:solidFill>
-                  <a:srgbClr val="666666"/>
-                </a:solidFill>
-                <a:latin typeface="Courier"/>
-              </a:rPr>
-              <a:t>);</a:t>
-            </a:r>
-            <a:r>
-              <a:rPr>
-                <a:latin typeface="Courier"/>
-              </a:rPr>
-              <a:t> state </a:t>
-            </a:r>
-            <a:r>
-              <a:rPr>
-                <a:solidFill>
-                  <a:srgbClr val="666666"/>
-                </a:solidFill>
-                <a:latin typeface="Courier"/>
-              </a:rPr>
-              <a:t>=</a:t>
-            </a:r>
-            <a:r>
-              <a:rPr>
-                <a:latin typeface="Courier"/>
-              </a:rPr>
-              <a:t> S_BUILD</a:t>
-            </a:r>
-            <a:r>
-              <a:rPr>
-                <a:solidFill>
-                  <a:srgbClr val="666666"/>
-                </a:solidFill>
-                <a:latin typeface="Courier"/>
-              </a:rPr>
-              <a:t>;</a:t>
-            </a:r>
-            <a:r>
-              <a:rPr>
-                <a:latin typeface="Courier"/>
-              </a:rPr>
-              <a:t> </a:t>
-            </a:r>
-            <a:r>
-              <a:rPr>
-                <a:solidFill>
-                  <a:srgbClr val="666666"/>
-                </a:solidFill>
-                <a:latin typeface="Courier"/>
-              </a:rPr>
-              <a:t>}</a:t>
-            </a:r>
-            <a:br/>
-            <a:r>
-              <a:rPr>
-                <a:latin typeface="Courier"/>
-              </a:rPr>
-              <a:t>  </a:t>
-            </a:r>
-            <a:r>
-              <a:rPr b="1">
-                <a:solidFill>
-                  <a:srgbClr val="007020"/>
-                </a:solidFill>
-                <a:latin typeface="Courier"/>
-              </a:rPr>
-              <a:t>break</a:t>
-            </a:r>
-            <a:r>
-              <a:rPr>
-                <a:solidFill>
-                  <a:srgbClr val="666666"/>
-                </a:solidFill>
-                <a:latin typeface="Courier"/>
-              </a:rPr>
-              <a:t>;</a:t>
-            </a:r>
-            <a:br/>
-            <a:r>
-              <a:rPr b="1">
-                <a:solidFill>
-                  <a:srgbClr val="007020"/>
-                </a:solidFill>
-                <a:latin typeface="Courier"/>
-              </a:rPr>
-              <a:t>case</a:t>
-            </a:r>
-            <a:r>
-              <a:rPr>
-                <a:latin typeface="Courier"/>
-              </a:rPr>
-              <a:t> S_ALARM</a:t>
-            </a:r>
-            <a:r>
-              <a:rPr>
-                <a:solidFill>
-                  <a:srgbClr val="666666"/>
-                </a:solidFill>
-                <a:latin typeface="Courier"/>
-              </a:rPr>
-              <a:t>:</a:t>
-            </a:r>
-            <a:br/>
-            <a:r>
-              <a:rPr>
-                <a:latin typeface="Courier"/>
-              </a:rPr>
-              <a:t>  alarm </a:t>
-            </a:r>
-            <a:r>
-              <a:rPr>
-                <a:solidFill>
-                  <a:srgbClr val="666666"/>
-                </a:solidFill>
-                <a:latin typeface="Courier"/>
-              </a:rPr>
-              <a:t>=</a:t>
-            </a:r>
-            <a:r>
-              <a:rPr>
-                <a:latin typeface="Courier"/>
-              </a:rPr>
-              <a:t> </a:t>
-            </a:r>
-            <a:r>
-              <a:rPr>
-                <a:solidFill>
-                  <a:srgbClr val="40A070"/>
-                </a:solidFill>
-                <a:latin typeface="Courier"/>
-              </a:rPr>
-              <a:t>1</a:t>
-            </a:r>
-            <a:r>
-              <a:rPr>
-                <a:solidFill>
-                  <a:srgbClr val="666666"/>
-                </a:solidFill>
-                <a:latin typeface="Courier"/>
-              </a:rPr>
-              <a:t>;</a:t>
-            </a:r>
-            <a:r>
-              <a:rPr>
-                <a:latin typeface="Courier"/>
-              </a:rPr>
-              <a:t> digitalWrite</a:t>
-            </a:r>
-            <a:r>
-              <a:rPr>
-                <a:solidFill>
-                  <a:srgbClr val="666666"/>
-                </a:solidFill>
-                <a:latin typeface="Courier"/>
-              </a:rPr>
-              <a:t>(</a:t>
-            </a:r>
-            <a:r>
-              <a:rPr>
-                <a:latin typeface="Courier"/>
-              </a:rPr>
-              <a:t>BUZZER</a:t>
-            </a:r>
-            <a:r>
-              <a:rPr>
-                <a:solidFill>
-                  <a:srgbClr val="666666"/>
-                </a:solidFill>
-                <a:latin typeface="Courier"/>
-              </a:rPr>
-              <a:t>,</a:t>
-            </a:r>
-            <a:r>
-              <a:rPr>
-                <a:latin typeface="Courier"/>
-              </a:rPr>
-              <a:t> HIGH</a:t>
-            </a:r>
-            <a:r>
-              <a:rPr>
-                <a:solidFill>
-                  <a:srgbClr val="666666"/>
-                </a:solidFill>
-                <a:latin typeface="Courier"/>
-              </a:rPr>
-              <a:t>);</a:t>
-            </a:r>
-            <a:r>
-              <a:rPr>
-                <a:latin typeface="Courier"/>
-              </a:rPr>
-              <a:t>              </a:t>
-            </a:r>
-            <a:r>
-              <a:rPr i="1">
-                <a:solidFill>
-                  <a:srgbClr val="60A0B0"/>
-                </a:solidFill>
-                <a:latin typeface="Courier"/>
-              </a:rPr>
-              <a:t>// sound it</a:t>
-            </a:r>
-            <a:br/>
-            <a:r>
-              <a:rPr>
-                <a:latin typeface="Courier"/>
-              </a:rPr>
-              <a:t>  state </a:t>
-            </a:r>
-            <a:r>
-              <a:rPr>
-                <a:solidFill>
-                  <a:srgbClr val="666666"/>
-                </a:solidFill>
-                <a:latin typeface="Courier"/>
-              </a:rPr>
-              <a:t>=</a:t>
-            </a:r>
-            <a:r>
-              <a:rPr>
-                <a:latin typeface="Courier"/>
-              </a:rPr>
-              <a:t> S_BUILD</a:t>
-            </a:r>
-            <a:r>
-              <a:rPr>
-                <a:solidFill>
-                  <a:srgbClr val="666666"/>
-                </a:solidFill>
-                <a:latin typeface="Courier"/>
-              </a:rPr>
-              <a:t>;</a:t>
-            </a:r>
-            <a:r>
-              <a:rPr>
-                <a:latin typeface="Courier"/>
-              </a:rPr>
-              <a:t>                                    </a:t>
-            </a:r>
-            <a:r>
-              <a:rPr i="1">
-                <a:solidFill>
-                  <a:srgbClr val="60A0B0"/>
-                </a:solidFill>
-                <a:latin typeface="Courier"/>
-              </a:rPr>
-              <a:t>// still report</a:t>
-            </a:r>
-            <a:br/>
-            <a:r>
-              <a:rPr>
-                <a:latin typeface="Courier"/>
-              </a:rPr>
-              <a:t>  </a:t>
-            </a:r>
-            <a:r>
-              <a:rPr b="1">
-                <a:solidFill>
-                  <a:srgbClr val="007020"/>
-                </a:solidFill>
-                <a:latin typeface="Courier"/>
-              </a:rPr>
-              <a:t>break</a:t>
             </a:r>
             <a:r>
               <a:rPr>
@@ -4625,7 +4077,7 @@
             </a:pPr>
             <a:r>
               <a:rPr/>
-              <a:t>Code structure</a:t>
+              <a:t>Cloud deployment</a:t>
             </a:r>
           </a:p>
         </p:txBody>
@@ -4647,109 +4099,99 @@
           <a:p>
             <a:pPr lvl="0"/>
             <a:r>
-              <a:rPr>
-                <a:latin typeface="Courier"/>
-              </a:rPr>
-              <a:t>firmware/common/protocol.h</a:t>
-            </a:r>
-            <a:r>
-              <a:rPr/>
-              <a:t> — LoRa params, pin map, node IDs, packet schema, </a:t>
-            </a:r>
-            <a:r>
-              <a:rPr>
-                <a:latin typeface="Courier"/>
-              </a:rPr>
-              <a:t>USE_LORA</a:t>
-            </a:r>
-            <a:r>
-              <a:rPr/>
-              <a:t> switch.</a:t>
+              <a:rPr/>
+              <a:t>Flask </a:t>
+            </a:r>
+            <a:r>
+              <a:rPr>
+                <a:latin typeface="Courier"/>
+              </a:rPr>
+              <a:t>cloud_app.py</a:t>
+            </a:r>
+            <a:r>
+              <a:rPr/>
+              <a:t> as a </a:t>
+            </a:r>
+            <a:r>
+              <a:rPr b="1"/>
+              <a:t>systemd service</a:t>
+            </a:r>
+            <a:r>
+              <a:rPr/>
+              <a:t> on AWS EC2, </a:t>
+            </a:r>
+            <a:r>
+              <a:rPr b="1"/>
+              <a:t>port 8080</a:t>
+            </a:r>
+            <a:r>
+              <a:rPr/>
+              <a:t>, own venv.</a:t>
             </a:r>
           </a:p>
           <a:p>
             <a:pPr lvl="0"/>
             <a:r>
-              <a:rPr>
-                <a:latin typeface="Courier"/>
-              </a:rPr>
-              <a:t>firmware/node_a</a:t>
-            </a:r>
-            <a:r>
-              <a:rPr/>
-              <a:t> / </a:t>
-            </a:r>
-            <a:r>
-              <a:rPr>
-                <a:latin typeface="Courier"/>
-              </a:rPr>
-              <a:t>node_b</a:t>
-            </a:r>
-            <a:r>
-              <a:rPr/>
-              <a:t> / </a:t>
-            </a:r>
-            <a:r>
-              <a:rPr>
-                <a:latin typeface="Courier"/>
-              </a:rPr>
-              <a:t>gateway</a:t>
-            </a:r>
-            <a:r>
-              <a:rPr/>
-              <a:t> — the three sketches (one state machine each).</a:t>
+              <a:rPr/>
+              <a:t>Co-tenant box runs an unrelated service on 80/443 — </a:t>
+            </a:r>
+            <a:r>
+              <a:rPr b="1"/>
+              <a:t>isolated by port</a:t>
+            </a:r>
+            <a:r>
+              <a:rPr/>
+              <a:t>, untouched.</a:t>
             </a:r>
           </a:p>
           <a:p>
             <a:pPr lvl="0"/>
             <a:r>
-              <a:rPr>
-                <a:latin typeface="Courier"/>
-              </a:rPr>
-              <a:t>dashboard/dashboard.py</a:t>
-            </a:r>
-            <a:r>
-              <a:rPr/>
-              <a:t> — Flask + pyserial live web dashboard, </a:t>
-            </a:r>
-            <a:r>
-              <a:rPr>
-                <a:latin typeface="Courier"/>
-              </a:rPr>
-              <a:t>--fake</a:t>
-            </a:r>
-            <a:r>
-              <a:rPr/>
-              <a:t> mode for hardware-free testing.</a:t>
-            </a:r>
-          </a:p>
-          <a:p>
-            <a:pPr lvl="0" indent="0" marL="0">
-              <a:buNone/>
-            </a:pPr>
+              <a:rPr/>
+              <a:t>One SG rule opens 8080; ingest gated by an </a:t>
+            </a:r>
             <a:r>
               <a:rPr b="1"/>
-              <a:t>Design decision:</a:t>
-            </a:r>
-            <a:r>
-              <a:rPr/>
-              <a:t> compact </a:t>
+              <a:t>X-Token</a:t>
+            </a:r>
+            <a:r>
+              <a:rPr/>
+              <a:t> secret.</a:t>
+            </a:r>
+          </a:p>
+          <a:p>
+            <a:pPr lvl="0"/>
+            <a:r>
+              <a:rPr/>
+              <a:t>Route 53 → </a:t>
+            </a:r>
+            <a:r>
+              <a:rPr>
+                <a:latin typeface="Courier"/>
+              </a:rPr>
+              <a:t>iot.gabr.online</a:t>
+            </a:r>
+            <a:r>
+              <a:rPr/>
+              <a:t>. Token + WiFi creds </a:t>
             </a:r>
             <a:r>
               <a:rPr b="1"/>
-              <a:t>CSV on the radio</a:t>
-            </a:r>
-            <a:r>
-              <a:rPr/>
-              <a:t> (tiny packet, no JSON lib on the nodes) → JSON built once </a:t>
-            </a:r>
-            <a:r>
-              <a:rPr b="1"/>
-              <a:t>on the gateway</a:t>
-            </a:r>
-            <a:r>
-              <a:rPr/>
-              <a:t> for the dashboard.</a:t>
+              <a:t>gitignored</a:t>
+            </a:r>
+            <a:r>
+              <a:rPr/>
+              <a:t> (</a:t>
+            </a:r>
+            <a:r>
+              <a:rPr>
+                <a:latin typeface="Courier"/>
+              </a:rPr>
+              <a:t>secrets.h</a:t>
+            </a:r>
+            <a:r>
+              <a:rPr/>
+              <a:t>).</a:t>
             </a:r>
           </a:p>
         </p:txBody>
@@ -4821,11 +4263,11 @@
             </a:pPr>
             <a:r>
               <a:rPr b="1"/>
-              <a:t>Intrusion alarm state</a:t>
-            </a:r>
-            <a:r>
-              <a:rPr/>
-              <a:t> — motion + door-open → buzzer + flagged packet.</a:t>
+              <a:t>Bidirectional LoRa</a:t>
+            </a:r>
+            <a:r>
+              <a:rPr/>
+              <a:t> — gateway ACKs, node confirms; ACK before cloud POST.</a:t>
             </a:r>
           </a:p>
           <a:p>
@@ -4834,11 +4276,11 @@
             </a:pPr>
             <a:r>
               <a:rPr b="1"/>
-              <a:t>Gateway link-stats heartbeat</a:t>
-            </a:r>
-            <a:r>
-              <a:rPr/>
-              <a:t> — per-node packet counts + RSSI every 5 s → offline detection + packet-loss measurement.</a:t>
+              <a:t>WiFi cloud uplink</a:t>
+            </a:r>
+            <a:r>
+              <a:rPr/>
+              <a:t> — token-secured AWS dashboard reachable anywhere.</a:t>
             </a:r>
           </a:p>
           <a:p>
@@ -4847,21 +4289,11 @@
             </a:pPr>
             <a:r>
               <a:rPr b="1"/>
-              <a:t>Hardware-independent demo path</a:t>
-            </a:r>
-            <a:r>
-              <a:rPr/>
-              <a:t> — </a:t>
-            </a:r>
-            <a:r>
-              <a:rPr>
-                <a:latin typeface="Courier"/>
-              </a:rPr>
-              <a:t>USE_LORA 0</a:t>
-            </a:r>
-            <a:r>
-              <a:rPr/>
-              <a:t> sends straight to USB if a radio fails on the day; same dashboard.</a:t>
+              <a:t>Environment-safety ALARM state</a:t>
+            </a:r>
+            <a:r>
+              <a:rPr/>
+              <a:t> — overheat / dark+humid; LDR participates.</a:t>
             </a:r>
           </a:p>
           <a:p>
@@ -4870,11 +4302,11 @@
             </a:pPr>
             <a:r>
               <a:rPr b="1"/>
-              <a:t>Self-healing firmware</a:t>
-            </a:r>
-            <a:r>
-              <a:rPr/>
-              <a:t> — any fault routes to ERROR and auto-retries instead of freezing.</a:t>
+              <a:t>Self-healing + graceful degradation</a:t>
+            </a:r>
+            <a:r>
+              <a:rPr/>
+              <a:t> — faults retry; WiFi loss ≠ outage.</a:t>
             </a:r>
           </a:p>
           <a:p>
@@ -4883,11 +4315,34 @@
             </a:pPr>
             <a:r>
               <a:rPr b="1"/>
-              <a:t>Live styled web dashboard</a:t>
-            </a:r>
-            <a:r>
-              <a:rPr/>
-              <a:t> — online/offline per node, animated alarm banner, projector-ready.</a:t>
+              <a:t>Hardware-independent demo path</a:t>
+            </a:r>
+            <a:r>
+              <a:rPr/>
+              <a:t> — </a:t>
+            </a:r>
+            <a:r>
+              <a:rPr>
+                <a:latin typeface="Courier"/>
+              </a:rPr>
+              <a:t>USE_LORA 0</a:t>
+            </a:r>
+            <a:r>
+              <a:rPr/>
+              <a:t> → straight to USB.</a:t>
+            </a:r>
+          </a:p>
+          <a:p>
+            <a:pPr lvl="0" indent="-342900" marL="342900">
+              <a:buAutoNum type="arabicPeriod"/>
+            </a:pPr>
+            <a:r>
+              <a:rPr b="1"/>
+              <a:t>Secrets hygiene</a:t>
+            </a:r>
+            <a:r>
+              <a:rPr/>
+              <a:t> — no credentials in committed code.</a:t>
             </a:r>
           </a:p>
         </p:txBody>
@@ -4957,17 +4412,7 @@
             <a:pPr lvl="0"/>
             <a:r>
               <a:rPr/>
-              <a:t>Dashboard verified hardware-free via </a:t>
-            </a:r>
-            <a:r>
-              <a:rPr>
-                <a:latin typeface="Courier"/>
-              </a:rPr>
-              <a:t>--fake</a:t>
-            </a:r>
-            <a:r>
-              <a:rPr/>
-              <a:t>: page renders, </a:t>
+              <a:t>Cloud: no/bad token → 403, good token → 204, packet shows in </a:t>
             </a:r>
             <a:r>
               <a:rPr>
@@ -4977,7 +4422,7 @@
             </a:r>
             <a:r>
               <a:rPr/>
-              <a:t> valid, counters advance, alarm banner toggles. </a:t>
+              <a:t>. </a:t>
             </a:r>
             <a:r>
               <a:rPr b="1"/>
@@ -4988,31 +4433,39 @@
             <a:pPr lvl="0"/>
             <a:r>
               <a:rPr/>
-              <a:t>Each board prints a boot banner; INIT reports per-subsystem OK; faults auto-retry.</a:t>
+              <a:t>WiFi: 2.4 GHz scan found hotspot −30..−45 dBm; gateway joined (172.20.10.x), POST 204. </a:t>
+            </a:r>
+            <a:r>
+              <a:rPr b="1"/>
+              <a:t>Pass.</a:t>
             </a:r>
           </a:p>
           <a:p>
             <a:pPr lvl="0"/>
             <a:r>
               <a:rPr/>
-              <a:t>Packet </a:t>
-            </a:r>
-            <a:r>
-              <a:rPr>
-                <a:latin typeface="Courier"/>
-              </a:rPr>
-              <a:t>seq</a:t>
-            </a:r>
-            <a:r>
-              <a:rPr/>
-              <a:t> counter + gateway counts → packet-loss visible.</a:t>
+              <a:t>Dashboard </a:t>
+            </a:r>
+            <a:r>
+              <a:rPr>
+                <a:latin typeface="Courier"/>
+              </a:rPr>
+              <a:t>--fake</a:t>
+            </a:r>
+            <a:r>
+              <a:rPr/>
+              <a:t>: renders, counters advance, day/night + alarm toggle. </a:t>
+            </a:r>
+            <a:r>
+              <a:rPr b="1"/>
+              <a:t>Pass.</a:t>
             </a:r>
           </a:p>
           <a:p>
             <a:pPr lvl="0"/>
             <a:r>
               <a:rPr/>
-              <a:t>[FILL IN: real-hardware sensor sanity + measured RSSI at demo distance]</a:t>
+              <a:t>[FILL IN: real-hardware RSSI at demo distance + sensor sanity ticks]</a:t>
             </a:r>
           </a:p>
         </p:txBody>
@@ -5089,7 +4542,35 @@
             <a:pPr lvl="0"/>
             <a:r>
               <a:rPr/>
-              <a:t>Shows: power on gateway → dashboard “online”, power node B → live temp/hum, wave hand → motion, open “door” magnet → alarm banner + buzzer, power node A → light reading reacts to a torch.</a:t>
+              <a:t>Power gateway → </a:t>
+            </a:r>
+            <a:r>
+              <a:rPr>
+                <a:latin typeface="Courier"/>
+              </a:rPr>
+              <a:t># WiFi OK</a:t>
+            </a:r>
+            <a:r>
+              <a:rPr/>
+              <a:t>; power Node A → dashboard ONLINE + </a:t>
+            </a:r>
+            <a:r>
+              <a:rPr>
+                <a:latin typeface="Courier"/>
+              </a:rPr>
+              <a:t>ACK ok</a:t>
+            </a:r>
+            <a:r>
+              <a:rPr/>
+              <a:t> on node serial; cover LDR → NIGHT; warm DHT22 → </a:t>
+            </a:r>
+            <a:r>
+              <a:rPr b="1"/>
+              <a:t>ENVIRONMENT ALARM</a:t>
+            </a:r>
+            <a:r>
+              <a:rPr/>
+              <a:t> banner; remove → clears.</a:t>
             </a:r>
           </a:p>
         </p:txBody>
@@ -5159,21 +4640,21 @@
             <a:pPr lvl="0"/>
             <a:r>
               <a:rPr/>
-              <a:t>Met brief (idea #4), extended to a real wireless sensor network.</a:t>
+              <a:t>Met brief (idea #4); extended to a bidirectional link + cloud dashboard with an on-board safety state.</a:t>
             </a:r>
           </a:p>
           <a:p>
             <a:pPr lvl="0"/>
             <a:r>
               <a:rPr/>
-              <a:t>Clean FSM firmware, documented protocol, live dashboard, 5 bonus features.</a:t>
+              <a:t>Clean FSM firmware, documented protocol, secrets hygiene, 6 bonus features.</a:t>
             </a:r>
           </a:p>
           <a:p>
             <a:pPr lvl="0"/>
             <a:r>
               <a:rPr/>
-              <a:t>Future: return path (gateway→node), swap USB for WiFi/MQTT, more nodes (protocol already namespaces by node ID).</a:t>
+              <a:t>Future: TLS on the uplink, gateway→node command path on the ACK channel, more nodes (protocol namespaces by node ID).</a:t>
             </a:r>
           </a:p>
           <a:p>
@@ -5260,52 +4741,54 @@
             </a:r>
             <a:r>
               <a:rPr/>
-              <a:t>, extended.</a:t>
+              <a:t>, extended end to end.</a:t>
             </a:r>
           </a:p>
           <a:p>
             <a:pPr lvl="0"/>
             <a:r>
               <a:rPr/>
-              <a:t>Instead of one board: </a:t>
+              <a:t>A </a:t>
             </a:r>
             <a:r>
               <a:rPr b="1"/>
-              <a:t>two LoRa sensor nodes + a gateway</a:t>
-            </a:r>
-            <a:r>
-              <a:rPr/>
-              <a:t> (three ESP32s).</a:t>
+              <a:t>bidirectional LoRa link</a:t>
+            </a:r>
+            <a:r>
+              <a:rPr/>
+              <a:t> + a </a:t>
+            </a:r>
+            <a:r>
+              <a:rPr b="1"/>
+              <a:t>WiFi-to-cloud dashboard on AWS</a:t>
+            </a:r>
+            <a:r>
+              <a:rPr/>
+              <a:t>.</a:t>
             </a:r>
           </a:p>
           <a:p>
             <a:pPr lvl="0"/>
             <a:r>
               <a:rPr/>
-              <a:t>Nodes read sensors → transmit over </a:t>
-            </a:r>
-            <a:r>
-              <a:rPr b="1"/>
-              <a:t>433 MHz LoRa</a:t>
-            </a:r>
-            <a:r>
-              <a:rPr/>
-              <a:t> → gateway → </a:t>
-            </a:r>
-            <a:r>
-              <a:rPr b="1"/>
-              <a:t>USB serial</a:t>
-            </a:r>
-            <a:r>
-              <a:rPr/>
-              <a:t> → live laptop dashboard.</a:t>
+              <a:t>Node reads sensors → safety rule → 433 MHz LoRa → gateway → WiFi/HTTP → AWS Flask → live web dashboard at </a:t>
+            </a:r>
+            <a:r>
+              <a:rPr>
+                <a:latin typeface="Courier"/>
+              </a:rPr>
+              <a:t>iot.gabr.online:8080</a:t>
+            </a:r>
+            <a:r>
+              <a:rPr/>
+              <a:t>.</a:t>
             </a:r>
           </a:p>
           <a:p>
             <a:pPr lvl="0"/>
             <a:r>
               <a:rPr/>
-              <a:t>Demonstrates: I²C, 1-wire digital, GPIO, SPI+RF, UART-to-host, and an explicit finite-state-machine firmware on every board.</a:t>
+              <a:t>Demonstrates: 1-wire digital, ADC, GPIO, SPI+RF, half-duplex bidirectional radio, ESP32 WiFi + HTTP client, token-secured cloud API, FSM firmware with an EVAL/ALARM branch.</a:t>
             </a:r>
           </a:p>
         </p:txBody>
@@ -5441,7 +4924,7 @@
                       </a:pPr>
                       <a:r>
                         <a:rPr/>
-                        <a:t>[e.g. Node A firmware + sensor wiring + testing]</a:t>
+                        <a:t>[e.g. Node A firmware + sensors + the EVAL/ALARM rule]</a:t>
                       </a:r>
                     </a:p>
                   </a:txBody>
@@ -5473,7 +4956,7 @@
                       </a:pPr>
                       <a:r>
                         <a:rPr/>
-                        <a:t>[e.g. Node B firmware + alarm logic + buzzer]</a:t>
+                        <a:t>[e.g. gateway firmware + the bidirectional ACK]</a:t>
                       </a:r>
                     </a:p>
                   </a:txBody>
@@ -5505,7 +4988,7 @@
                       </a:pPr>
                       <a:r>
                         <a:rPr/>
-                        <a:t>[e.g. Gateway firmware + LoRa bring-up]</a:t>
+                        <a:t>[e.g. WiFi + cloud service + AWS deployment]</a:t>
                       </a:r>
                     </a:p>
                   </a:txBody>
@@ -5537,7 +5020,7 @@
                       </a:pPr>
                       <a:r>
                         <a:rPr/>
-                        <a:t>[e.g. Dashboard + report + presentation]</a:t>
+                        <a:t>[e.g. dashboard + report + presentation]</a:t>
                       </a:r>
                     </a:p>
                   </a:txBody>
@@ -5663,33 +5146,46 @@
               <a:rPr>
                 <a:latin typeface="Courier"/>
               </a:rPr>
-              <a:t> [Node A]  Weather       \
-  DHT22 + BH1750           \  LoRa 433 MHz
-                            &gt;---&gt;  [Gateway]  --USB serial--&gt;  [Laptop]
- [Node B]  Env./Security   /       ESP32+LoRa     JSON lines    dashboard
-  DHT22 + PIR + reed      /        (no sensors)
-  + buzzer (alarm)</a:t>
+              <a:t> [Node A]  --LoRa data--&gt;  [Gateway]  --WiFi/HTTP--&gt;  [AWS EC2]  --&gt; browser
+  DHT22 + photoresistor     ESP32+LoRa                 Flask :8080  iot.gabr.online
+  (EVAL/ALARM bonus)  &lt;--LoRa ACK--  + WiFi            (token-gated)</a:t>
             </a:r>
           </a:p>
           <a:p>
             <a:pPr lvl="0"/>
             <a:r>
               <a:rPr/>
-              <a:t>Nodes are transmit-only; gateway is RX on radio, TX on USB.</a:t>
+              <a:t>LoRa hop is </a:t>
+            </a:r>
+            <a:r>
+              <a:rPr b="1"/>
+              <a:t>bidirectional</a:t>
+            </a:r>
+            <a:r>
+              <a:rPr/>
+              <a:t> (gateway ACKs every packet, node confirms).</a:t>
             </a:r>
           </a:p>
           <a:p>
             <a:pPr lvl="0"/>
             <a:r>
               <a:rPr/>
-              <a:t>No WiFi / broker in the room → rock-solid demo.</a:t>
+              <a:t>WiFi is a </a:t>
+            </a:r>
+            <a:r>
+              <a:rPr b="1"/>
+              <a:t>non-fatal added stage</a:t>
+            </a:r>
+            <a:r>
+              <a:rPr/>
+              <a:t> — lose it and the link still LoRa-ACKs + prints to USB.</a:t>
             </a:r>
           </a:p>
           <a:p>
             <a:pPr lvl="0"/>
             <a:r>
               <a:rPr i="1"/>
-              <a:t>(Vector version of every diagram is in the report PDF.)</a:t>
+              <a:t>(Vector diagrams are in the report PDF.)</a:t>
             </a:r>
           </a:p>
         </p:txBody>
@@ -5827,7 +5323,7 @@
                       </a:pPr>
                       <a:r>
                         <a:rPr/>
-                        <a:t>ESP32-WROOM ×3</a:t>
+                        <a:t>ESP32-WROOM ×2</a:t>
                       </a:r>
                     </a:p>
                   </a:txBody>
@@ -5857,7 +5353,7 @@
                       </a:pPr>
                       <a:r>
                         <a:rPr/>
-                        <a:t>MCU for each node + gateway</a:t>
+                        <a:t>MCU for node + gateway</a:t>
                       </a:r>
                     </a:p>
                   </a:txBody>
@@ -5874,7 +5370,7 @@
                       </a:pPr>
                       <a:r>
                         <a:rPr/>
-                        <a:t>LoRa Ra-01 (SX1278) ×3</a:t>
+                        <a:t>LoRa Ra-01 (SX1278) ×2</a:t>
                       </a:r>
                     </a:p>
                   </a:txBody>
@@ -5904,7 +5400,7 @@
                       </a:pPr>
                       <a:r>
                         <a:rPr/>
-                        <a:t>433 MHz radio</a:t>
+                        <a:t>433 MHz radio (both boards)</a:t>
                       </a:r>
                     </a:p>
                   </a:txBody>
@@ -5921,7 +5417,7 @@
                       </a:pPr>
                       <a:r>
                         <a:rPr/>
-                        <a:t>DHT22 ×2</a:t>
+                        <a:t>DHT22 ×1</a:t>
                       </a:r>
                     </a:p>
                   </a:txBody>
@@ -5951,7 +5447,7 @@
                       </a:pPr>
                       <a:r>
                         <a:rPr/>
-                        <a:t>Temp + humidity</a:t>
+                        <a:t>Temp + humidity, Node A</a:t>
                       </a:r>
                     </a:p>
                   </a:txBody>
@@ -5968,7 +5464,7 @@
                       </a:pPr>
                       <a:r>
                         <a:rPr/>
-                        <a:t>BH1750 ×1</a:t>
+                        <a:t>Photoresistor ×1</a:t>
                       </a:r>
                     </a:p>
                   </a:txBody>
@@ -5983,7 +5479,7 @@
                       </a:pPr>
                       <a:r>
                         <a:rPr/>
-                        <a:t>I²C</a:t>
+                        <a:t>Analog (ADC)</a:t>
                       </a:r>
                     </a:p>
                   </a:txBody>
@@ -5998,148 +5494,7 @@
                       </a:pPr>
                       <a:r>
                         <a:rPr/>
-                        <a:t>Light (lux), Node A</a:t>
-                      </a:r>
-                    </a:p>
-                  </a:txBody>
-                </a:tc>
-              </a:tr>
-              <a:tr h="0">
-                <a:tc>
-                  <a:txBody>
-                    <a:bodyPr/>
-                    <a:lstStyle/>
-                    <a:p>
-                      <a:pPr lvl="0" indent="0" marL="0">
-                        <a:buNone/>
-                      </a:pPr>
-                      <a:r>
-                        <a:rPr/>
-                        <a:t>HC-SR501 PIR ×1</a:t>
-                      </a:r>
-                    </a:p>
-                  </a:txBody>
-                </a:tc>
-                <a:tc>
-                  <a:txBody>
-                    <a:bodyPr/>
-                    <a:lstStyle/>
-                    <a:p>
-                      <a:pPr lvl="0" indent="0" marL="0">
-                        <a:buNone/>
-                      </a:pPr>
-                      <a:r>
-                        <a:rPr/>
-                        <a:t>GPIO</a:t>
-                      </a:r>
-                    </a:p>
-                  </a:txBody>
-                </a:tc>
-                <a:tc>
-                  <a:txBody>
-                    <a:bodyPr/>
-                    <a:lstStyle/>
-                    <a:p>
-                      <a:pPr lvl="0" indent="0" marL="0">
-                        <a:buNone/>
-                      </a:pPr>
-                      <a:r>
-                        <a:rPr/>
-                        <a:t>Motion, Node B</a:t>
-                      </a:r>
-                    </a:p>
-                  </a:txBody>
-                </a:tc>
-              </a:tr>
-              <a:tr h="0">
-                <a:tc>
-                  <a:txBody>
-                    <a:bodyPr/>
-                    <a:lstStyle/>
-                    <a:p>
-                      <a:pPr lvl="0" indent="0" marL="0">
-                        <a:buNone/>
-                      </a:pPr>
-                      <a:r>
-                        <a:rPr/>
-                        <a:t>Reed switch ×1</a:t>
-                      </a:r>
-                    </a:p>
-                  </a:txBody>
-                </a:tc>
-                <a:tc>
-                  <a:txBody>
-                    <a:bodyPr/>
-                    <a:lstStyle/>
-                    <a:p>
-                      <a:pPr lvl="0" indent="0" marL="0">
-                        <a:buNone/>
-                      </a:pPr>
-                      <a:r>
-                        <a:rPr/>
-                        <a:t>GPIO</a:t>
-                      </a:r>
-                    </a:p>
-                  </a:txBody>
-                </a:tc>
-                <a:tc>
-                  <a:txBody>
-                    <a:bodyPr/>
-                    <a:lstStyle/>
-                    <a:p>
-                      <a:pPr lvl="0" indent="0" marL="0">
-                        <a:buNone/>
-                      </a:pPr>
-                      <a:r>
-                        <a:rPr/>
-                        <a:t>Door open/closed, Node B</a:t>
-                      </a:r>
-                    </a:p>
-                  </a:txBody>
-                </a:tc>
-              </a:tr>
-              <a:tr h="0">
-                <a:tc>
-                  <a:txBody>
-                    <a:bodyPr/>
-                    <a:lstStyle/>
-                    <a:p>
-                      <a:pPr lvl="0" indent="0" marL="0">
-                        <a:buNone/>
-                      </a:pPr>
-                      <a:r>
-                        <a:rPr/>
-                        <a:t>Active buzzer ×1</a:t>
-                      </a:r>
-                    </a:p>
-                  </a:txBody>
-                </a:tc>
-                <a:tc>
-                  <a:txBody>
-                    <a:bodyPr/>
-                    <a:lstStyle/>
-                    <a:p>
-                      <a:pPr lvl="0" indent="0" marL="0">
-                        <a:buNone/>
-                      </a:pPr>
-                      <a:r>
-                        <a:rPr/>
-                        <a:t>GPIO</a:t>
-                      </a:r>
-                    </a:p>
-                  </a:txBody>
-                </a:tc>
-                <a:tc>
-                  <a:txBody>
-                    <a:bodyPr/>
-                    <a:lstStyle/>
-                    <a:p>
-                      <a:pPr lvl="0" indent="0" marL="0">
-                        <a:buNone/>
-                      </a:pPr>
-                      <a:r>
-                        <a:rPr/>
-                        <a:t>Alarm, Node B (bonus)</a:t>
+                        <a:t>Light / day-night, Node A</a:t>
                       </a:r>
                     </a:p>
                   </a:txBody>
@@ -6191,7 +5546,7 @@
             </a:pPr>
             <a:r>
               <a:rPr/>
-              <a:t>Circuit schematic (Node B shown)</a:t>
+              <a:t>Circuit schematic (Node A)</a:t>
             </a:r>
           </a:p>
         </p:txBody>
@@ -6218,11 +5573,9 @@
               <a:rPr>
                 <a:latin typeface="Courier"/>
               </a:rPr>
-              <a:t>            +-----------+ GPIO4   DHT22
-            |           |-------- (temp/hum)
-   Ra-01 ---|  ESP32    | GPIO34  HC-SR501 PIR
-   (SPI)    |  Node B   | GPIO32  Reed switch (INPUT_PULLUP -&gt; GND)
-            |           | GPIO25  Buzzer
+              <a:t>            +-----------+ GPIO4   DHT22 (temp/hum, 1-wire)
+   Ra-01 ---|  ESP32    |
+   (SPI)    |  Node A   | GPIO34  Photoresistor AO (ADC1)
             +-----------+</a:t>
             </a:r>
           </a:p>
@@ -6230,7 +5583,7 @@
             <a:pPr lvl="0"/>
             <a:r>
               <a:rPr/>
-              <a:t>Ra-01 powered at </a:t>
+              <a:t>Ra-01 at </a:t>
             </a:r>
             <a:r>
               <a:rPr b="1"/>
@@ -6238,21 +5591,21 @@
             </a:r>
             <a:r>
               <a:rPr/>
-              <a:t> (never 5 V) + 100 nF decoupling.</a:t>
+              <a:t> (never 5 V) + 100 nF + ~17 cm antenna wire.</a:t>
             </a:r>
           </a:p>
           <a:p>
             <a:pPr lvl="0"/>
             <a:r>
               <a:rPr/>
-              <a:t>LoRa SPI bus: SCK 18 / MISO 19 / MOSI 23, NSS 5 / RST 27 / DIO0 26.</a:t>
+              <a:t>LoRa SPI: SCK 18 / MISO 19 / MOSI 23, NSS 5 / RST 27 / DIO0 26.</a:t>
             </a:r>
           </a:p>
           <a:p>
             <a:pPr lvl="0"/>
             <a:r>
               <a:rPr/>
-              <a:t>Node A swaps PIR/reed/buzzer for a BH1750 on I²C (SDA 21, SCL 22).</a:t>
+              <a:t>Gateway = same ESP32 + Ra-01, no sensors.</a:t>
             </a:r>
           </a:p>
         </p:txBody>
@@ -6299,7 +5652,7 @@
             </a:pPr>
             <a:r>
               <a:rPr/>
-              <a:t>State machine — the firmware architecture</a:t>
+              <a:t>State machine — Node A (bonus + ACK)</a:t>
             </a:r>
           </a:p>
         </p:txBody>
@@ -6319,67 +5672,50 @@
           <a:bodyPr/>
           <a:lstStyle/>
           <a:p>
-            <a:pPr lvl="0" indent="0" marL="0">
+            <a:pPr lvl="0" indent="0">
               <a:buNone/>
             </a:pPr>
             <a:r>
-              <a:rPr/>
-              <a:t>Every board = one </a:t>
-            </a:r>
-            <a:r>
-              <a:rPr>
-                <a:latin typeface="Courier"/>
-              </a:rPr>
-              <a:t>enum</a:t>
-            </a:r>
-            <a:r>
-              <a:rPr/>
-              <a:t> of states + a </a:t>
-            </a:r>
-            <a:r>
-              <a:rPr>
-                <a:latin typeface="Courier"/>
-              </a:rPr>
-              <a:t>switch</a:t>
-            </a:r>
-            <a:r>
-              <a:rPr/>
-              <a:t> in </a:t>
-            </a:r>
-            <a:r>
-              <a:rPr>
-                <a:latin typeface="Courier"/>
-              </a:rPr>
-              <a:t>loop()</a:t>
-            </a:r>
-            <a:r>
-              <a:rPr/>
-              <a:t>. One </a:t>
-            </a:r>
-            <a:r>
-              <a:rPr>
-                <a:latin typeface="Courier"/>
-              </a:rPr>
-              <a:t>case</a:t>
-            </a:r>
-            <a:r>
-              <a:rPr/>
-              <a:t> = one state. Direct 1:1 mapping to the diagram.</a:t>
-            </a:r>
-          </a:p>
-          <a:p>
-            <a:pPr lvl="0" indent="0">
-              <a:buNone/>
-            </a:pPr>
-            <a:r>
-              <a:rPr>
-                <a:latin typeface="Courier"/>
-              </a:rPr>
-              <a:t> Node:    INIT -&gt; READ -&gt; BUILD -&gt; SEND -&gt; WAIT -.
-            \      \_ read fail _.                 \_ period _.
-             \_ init fail _.      v                            v
-                            ERROR &lt;----------------------------'
-                              \_ retry _-&gt; INIT</a:t>
+              <a:rPr>
+                <a:latin typeface="Courier"/>
+              </a:rPr>
+              <a:t> INIT -&gt; READ -&gt; EVAL --(hot|dark&amp;humid)--&gt; ALARM --.
+                   \                                  \ alarm=1
+                    \--(safe)--&gt; BUILD &lt;--------------'
+                                   |
+        WAIT &lt;- WAITACK &lt;- SEND &lt;--'   (WAITACK listens ~600ms for ACK)</a:t>
+            </a:r>
+          </a:p>
+          <a:p>
+            <a:pPr lvl="0"/>
+            <a:r>
+              <a:rPr b="1"/>
+              <a:t>ALARM</a:t>
+            </a:r>
+            <a:r>
+              <a:rPr/>
+              <a:t> is a real extra state (overheat OR dark+humid).</a:t>
+            </a:r>
+          </a:p>
+          <a:p>
+            <a:pPr lvl="0"/>
+            <a:r>
+              <a:rPr b="1"/>
+              <a:t>WAITACK</a:t>
+            </a:r>
+            <a:r>
+              <a:rPr/>
+              <a:t> flips the radio to RX and confirms the gateway’s </a:t>
+            </a:r>
+            <a:r>
+              <a:rPr>
+                <a:latin typeface="Courier"/>
+              </a:rPr>
+              <a:t>ACK,&lt;seq&gt;</a:t>
+            </a:r>
+            <a:r>
+              <a:rPr/>
+              <a:t>.</a:t>
             </a:r>
           </a:p>
         </p:txBody>
@@ -6426,7 +5762,7 @@
             </a:pPr>
             <a:r>
               <a:rPr/>
-              <a:t>State machine — Node B (the bonus branch)</a:t>
+              <a:t>State machine — Gateway (bridge)</a:t>
             </a:r>
           </a:p>
         </p:txBody>
@@ -6453,39 +5789,31 @@
               <a:rPr>
                 <a:latin typeface="Courier"/>
               </a:rPr>
-              <a:t> INIT -&gt; READ -&gt; EVAL --(motion &amp; door open)--&gt; ALARM --.
-                   \                                      \  buzzer on
-                    \--(safe)----------------&gt; BUILD &lt;-----'  alarm=1
-                                                 |
-                                       SEND &lt;----'--&gt; WAIT --&gt; READ</a:t>
+              <a:t> INIT(LoRa+WiFi) -&gt; LISTEN --(packet)--&gt; PARSE -&gt; EMIT -&gt; LISTEN
+                       \--(5s)--&gt; STATUS --^
+ EMIT = (1) LoRa ACK back  (2) USB print  (3) WiFi HTTP POST</a:t>
             </a:r>
           </a:p>
           <a:p>
             <a:pPr lvl="0"/>
             <a:r>
+              <a:rPr/>
+              <a:t>ACK is sent </a:t>
+            </a:r>
+            <a:r>
               <a:rPr b="1"/>
-              <a:t>ALARM is a real extra state</a:t>
-            </a:r>
-            <a:r>
-              <a:rPr/>
-              <a:t>, not just an </a:t>
-            </a:r>
-            <a:r>
-              <a:rPr>
-                <a:latin typeface="Courier"/>
-              </a:rPr>
-              <a:t>if</a:t>
-            </a:r>
-            <a:r>
-              <a:rPr/>
-              <a:t>.</a:t>
+              <a:t>before</a:t>
+            </a:r>
+            <a:r>
+              <a:rPr/>
+              <a:t> the POST — a slow hotspot can’t break the round-trip.</a:t>
             </a:r>
           </a:p>
           <a:p>
             <a:pPr lvl="0"/>
             <a:r>
               <a:rPr/>
-              <a:t>In ALARM the node re-evaluates every 0.5 s (vs 3 s) so the buzzer clears fast.</a:t>
+              <a:t>WiFi non-fatal: join fails → still ACK + USB, retry on heartbeat.</a:t>
             </a:r>
           </a:p>
         </p:txBody>

</xml_diff>